<commit_message>
ACL hop card news rev 3: add landing card before guideline card
The guideline card's jumping-biomechanics point covers landing, but the
earlier cards only showed propulsion. New card 05 puts the paper's
Figure 3 landing panel (knee band outlined) beside the Figure 2 landing
panel (knee violins outlined, Korean column labels): knee absorbs about
65% on landing vs about 12% in propulsion; the involved knee absorbs
less than the uninvolved one, and the uninvolved knee more than
controls. Guideline and lecturer cards move to 06 and 07 (7 cards).

Co-Authored-By: Claude Opus 5.5 <noreply@anthropic.com>
Claude-Session: https://claude.ai/code/session_01Co6TxBLNHGCdrCqCR9P85U
</commit_message>
<xml_diff>
--- a/content/acl-hop-distance-knee-work/adobe-express/acl-hop-distance-knee-work-express.pptx
+++ b/content/acl-hop-distance-knee-work/adobe-express/acl-hop-distance-knee-work-express.pptx
@@ -11,6 +11,7 @@
     <p:sldId id="259" r:id="rId6"/>
     <p:sldId id="260" r:id="rId7"/>
     <p:sldId id="261" r:id="rId8"/>
+    <p:sldId id="262" r:id="rId9"/>
   </p:sldIdLst>
   <p:sldSz cx="10287000" cy="12858750"/>
   <p:notesSz cx="6858000" cy="9144000"/>
@@ -3271,9 +3272,40 @@
           <a:chExt cx="0" cy="0"/>
         </a:xfrm>
       </p:grpSpPr>
+      <p:sp>
+        <p:nvSpPr>
+          <p:cNvPr id="2" name="연한 박스"/>
+          <p:cNvSpPr/>
+          <p:nvPr/>
+        </p:nvSpPr>
+        <p:spPr>
+          <a:xfrm>
+            <a:off x="914400" y="4369891"/>
+            <a:ext cx="2466975" cy="4601468"/>
+          </a:xfrm>
+          <a:prstGeom prst="roundRect">
+            <a:avLst>
+              <a:gd name="adj" fmla="val 6178"/>
+            </a:avLst>
+          </a:prstGeom>
+          <a:solidFill>
+            <a:srgbClr val="F0F7FC"/>
+          </a:solidFill>
+          <a:ln>
+            <a:noFill/>
+          </a:ln>
+        </p:spPr>
+        <p:txBody>
+          <a:bodyPr rtlCol="0" anchor="ctr"/>
+          <a:lstStyle/>
+          <a:p>
+            <a:endParaRPr lang="ko-KR"/>
+          </a:p>
+        </p:txBody>
+      </p:sp>
       <p:pic>
         <p:nvPicPr>
-          <p:cNvPr id="2" name="사진" descr="Aspetar 2023 가이드라인 Box 5 스포츠 복귀 최소 기준 머리글 원문"/>
+          <p:cNvPr id="3" name="사진" descr="Kotsifaki 2022 Figure 3 착지 구간 관절별 일 기여율"/>
           <p:cNvPicPr>
             <a:picLocks noChangeAspect="1"/>
           </p:cNvPicPr>
@@ -3287,17 +3319,164 @@
         </p:blipFill>
         <p:spPr>
           <a:xfrm>
-            <a:off x="1143000" y="4175671"/>
-            <a:ext cx="8001000" cy="2595562"/>
+            <a:off x="1028700" y="4484191"/>
+            <a:ext cx="2238375" cy="4372868"/>
           </a:xfrm>
           <a:prstGeom prst="rect">
             <a:avLst/>
           </a:prstGeom>
         </p:spPr>
       </p:pic>
+      <p:sp>
+        <p:nvSpPr>
+          <p:cNvPr id="4" name="연한 박스"/>
+          <p:cNvSpPr/>
+          <p:nvPr/>
+        </p:nvSpPr>
+        <p:spPr>
+          <a:xfrm>
+            <a:off x="1095375" y="5245150"/>
+            <a:ext cx="2158305" cy="57150"/>
+          </a:xfrm>
+          <a:prstGeom prst="rect">
+            <a:avLst/>
+          </a:prstGeom>
+          <a:solidFill>
+            <a:srgbClr val="CC414A"/>
+          </a:solidFill>
+          <a:ln>
+            <a:noFill/>
+          </a:ln>
+        </p:spPr>
+        <p:txBody>
+          <a:bodyPr rtlCol="0" anchor="ctr"/>
+          <a:lstStyle/>
+          <a:p>
+            <a:endParaRPr lang="ko-KR"/>
+          </a:p>
+        </p:txBody>
+      </p:sp>
+      <p:sp>
+        <p:nvSpPr>
+          <p:cNvPr id="5" name="연한 박스"/>
+          <p:cNvSpPr/>
+          <p:nvPr/>
+        </p:nvSpPr>
+        <p:spPr>
+          <a:xfrm>
+            <a:off x="1095375" y="7656016"/>
+            <a:ext cx="2158305" cy="57150"/>
+          </a:xfrm>
+          <a:prstGeom prst="rect">
+            <a:avLst/>
+          </a:prstGeom>
+          <a:solidFill>
+            <a:srgbClr val="CC414A"/>
+          </a:solidFill>
+          <a:ln>
+            <a:noFill/>
+          </a:ln>
+        </p:spPr>
+        <p:txBody>
+          <a:bodyPr rtlCol="0" anchor="ctr"/>
+          <a:lstStyle/>
+          <a:p>
+            <a:endParaRPr lang="ko-KR"/>
+          </a:p>
+        </p:txBody>
+      </p:sp>
+      <p:sp>
+        <p:nvSpPr>
+          <p:cNvPr id="6" name="연한 박스"/>
+          <p:cNvSpPr/>
+          <p:nvPr/>
+        </p:nvSpPr>
+        <p:spPr>
+          <a:xfrm>
+            <a:off x="1095375" y="5245150"/>
+            <a:ext cx="57150" cy="2468761"/>
+          </a:xfrm>
+          <a:prstGeom prst="rect">
+            <a:avLst/>
+          </a:prstGeom>
+          <a:solidFill>
+            <a:srgbClr val="CC414A"/>
+          </a:solidFill>
+          <a:ln>
+            <a:noFill/>
+          </a:ln>
+        </p:spPr>
+        <p:txBody>
+          <a:bodyPr rtlCol="0" anchor="ctr"/>
+          <a:lstStyle/>
+          <a:p>
+            <a:endParaRPr lang="ko-KR"/>
+          </a:p>
+        </p:txBody>
+      </p:sp>
+      <p:sp>
+        <p:nvSpPr>
+          <p:cNvPr id="7" name="연한 박스"/>
+          <p:cNvSpPr/>
+          <p:nvPr/>
+        </p:nvSpPr>
+        <p:spPr>
+          <a:xfrm>
+            <a:off x="3196530" y="5245150"/>
+            <a:ext cx="57150" cy="2468761"/>
+          </a:xfrm>
+          <a:prstGeom prst="rect">
+            <a:avLst/>
+          </a:prstGeom>
+          <a:solidFill>
+            <a:srgbClr val="CC414A"/>
+          </a:solidFill>
+          <a:ln>
+            <a:noFill/>
+          </a:ln>
+        </p:spPr>
+        <p:txBody>
+          <a:bodyPr rtlCol="0" anchor="ctr"/>
+          <a:lstStyle/>
+          <a:p>
+            <a:endParaRPr lang="ko-KR"/>
+          </a:p>
+        </p:txBody>
+      </p:sp>
+      <p:sp>
+        <p:nvSpPr>
+          <p:cNvPr id="8" name="연한 박스"/>
+          <p:cNvSpPr/>
+          <p:nvPr/>
+        </p:nvSpPr>
+        <p:spPr>
+          <a:xfrm>
+            <a:off x="3543300" y="4371826"/>
+            <a:ext cx="5829300" cy="4601468"/>
+          </a:xfrm>
+          <a:prstGeom prst="roundRect">
+            <a:avLst>
+              <a:gd name="adj" fmla="val 3312"/>
+            </a:avLst>
+          </a:prstGeom>
+          <a:solidFill>
+            <a:srgbClr val="F0F7FC"/>
+          </a:solidFill>
+          <a:ln>
+            <a:noFill/>
+          </a:ln>
+        </p:spPr>
+        <p:txBody>
+          <a:bodyPr rtlCol="0" anchor="ctr"/>
+          <a:lstStyle/>
+          <a:p>
+            <a:endParaRPr lang="ko-KR"/>
+          </a:p>
+        </p:txBody>
+      </p:sp>
       <p:pic>
         <p:nvPicPr>
-          <p:cNvPr id="3" name="사진" descr="Aspetar 2023 가이드라인 Box 5 Jumping biomechanics 원문"/>
+          <p:cNvPr id="9" name="사진" descr="Kotsifaki 2022 Figure 2 착지 구간 관절별 흡수 일"/>
           <p:cNvPicPr>
             <a:picLocks noChangeAspect="1"/>
           </p:cNvPicPr>
@@ -3311,8 +3490,8 @@
         </p:blipFill>
         <p:spPr>
           <a:xfrm>
-            <a:off x="1143000" y="6847433"/>
-            <a:ext cx="8001000" cy="1422053"/>
+            <a:off x="3657600" y="4486126"/>
+            <a:ext cx="5600700" cy="4372868"/>
           </a:xfrm>
           <a:prstGeom prst="rect">
             <a:avLst/>
@@ -3321,7 +3500,123 @@
       </p:pic>
       <p:sp>
         <p:nvSpPr>
-          <p:cNvPr id="4" name="B01 프레임"/>
+          <p:cNvPr id="10" name="연한 박스"/>
+          <p:cNvSpPr/>
+          <p:nvPr/>
+        </p:nvSpPr>
+        <p:spPr>
+          <a:xfrm>
+            <a:off x="5045273" y="5632847"/>
+            <a:ext cx="3862388" cy="38100"/>
+          </a:xfrm>
+          <a:prstGeom prst="rect">
+            <a:avLst/>
+          </a:prstGeom>
+          <a:solidFill>
+            <a:srgbClr val="CC414A"/>
+          </a:solidFill>
+          <a:ln>
+            <a:noFill/>
+          </a:ln>
+        </p:spPr>
+        <p:txBody>
+          <a:bodyPr rtlCol="0" anchor="ctr"/>
+          <a:lstStyle/>
+          <a:p>
+            <a:endParaRPr lang="ko-KR"/>
+          </a:p>
+        </p:txBody>
+      </p:sp>
+      <p:sp>
+        <p:nvSpPr>
+          <p:cNvPr id="11" name="연한 박스"/>
+          <p:cNvSpPr/>
+          <p:nvPr/>
+        </p:nvSpPr>
+        <p:spPr>
+          <a:xfrm>
+            <a:off x="5045273" y="8808541"/>
+            <a:ext cx="3862388" cy="38100"/>
+          </a:xfrm>
+          <a:prstGeom prst="rect">
+            <a:avLst/>
+          </a:prstGeom>
+          <a:solidFill>
+            <a:srgbClr val="CC414A"/>
+          </a:solidFill>
+          <a:ln>
+            <a:noFill/>
+          </a:ln>
+        </p:spPr>
+        <p:txBody>
+          <a:bodyPr rtlCol="0" anchor="ctr"/>
+          <a:lstStyle/>
+          <a:p>
+            <a:endParaRPr lang="ko-KR"/>
+          </a:p>
+        </p:txBody>
+      </p:sp>
+      <p:sp>
+        <p:nvSpPr>
+          <p:cNvPr id="12" name="연한 박스"/>
+          <p:cNvSpPr/>
+          <p:nvPr/>
+        </p:nvSpPr>
+        <p:spPr>
+          <a:xfrm>
+            <a:off x="5045273" y="5632847"/>
+            <a:ext cx="38100" cy="3213646"/>
+          </a:xfrm>
+          <a:prstGeom prst="rect">
+            <a:avLst/>
+          </a:prstGeom>
+          <a:solidFill>
+            <a:srgbClr val="CC414A"/>
+          </a:solidFill>
+          <a:ln>
+            <a:noFill/>
+          </a:ln>
+        </p:spPr>
+        <p:txBody>
+          <a:bodyPr rtlCol="0" anchor="ctr"/>
+          <a:lstStyle/>
+          <a:p>
+            <a:endParaRPr lang="ko-KR"/>
+          </a:p>
+        </p:txBody>
+      </p:sp>
+      <p:sp>
+        <p:nvSpPr>
+          <p:cNvPr id="13" name="연한 박스"/>
+          <p:cNvSpPr/>
+          <p:nvPr/>
+        </p:nvSpPr>
+        <p:spPr>
+          <a:xfrm>
+            <a:off x="8869561" y="5632847"/>
+            <a:ext cx="38100" cy="3213646"/>
+          </a:xfrm>
+          <a:prstGeom prst="rect">
+            <a:avLst/>
+          </a:prstGeom>
+          <a:solidFill>
+            <a:srgbClr val="CC414A"/>
+          </a:solidFill>
+          <a:ln>
+            <a:noFill/>
+          </a:ln>
+        </p:spPr>
+        <p:txBody>
+          <a:bodyPr rtlCol="0" anchor="ctr"/>
+          <a:lstStyle/>
+          <a:p>
+            <a:endParaRPr lang="ko-KR"/>
+          </a:p>
+        </p:txBody>
+      </p:sp>
+      <p:sp>
+        <p:nvSpPr>
+          <p:cNvPr id="14" name="B01 프레임"/>
           <p:cNvSpPr/>
           <p:nvPr/>
         </p:nvSpPr>
@@ -3352,14 +3647,14 @@
       </p:sp>
       <p:sp>
         <p:nvSpPr>
-          <p:cNvPr id="5" name="텍스트: 그래서 Aspetar는"/>
-          <p:cNvSpPr txBox="1"/>
-          <p:nvPr/>
-        </p:nvSpPr>
-        <p:spPr>
-          <a:xfrm>
-            <a:off x="1609130" y="1029081"/>
-            <a:ext cx="7068741" cy="962025"/>
+          <p:cNvPr id="15" name="텍스트: 착지 때는 무릎이"/>
+          <p:cNvSpPr txBox="1"/>
+          <p:nvPr/>
+        </p:nvSpPr>
+        <p:spPr>
+          <a:xfrm>
+            <a:off x="1897410" y="1029081"/>
+            <a:ext cx="6491883" cy="962025"/>
           </a:xfrm>
           <a:prstGeom prst="rect">
             <a:avLst/>
@@ -3390,13 +3685,24 @@
             <a:r>
               <a:rPr lang="ko-KR" altLang="en-US" sz="6300" b="0" i="0" spc="-220" kern="0" dirty="0">
                 <a:solidFill>
-                  <a:srgbClr val="121416"/>
+                  <a:srgbClr val="0879D8"/>
                 </a:solidFill>
                 <a:latin typeface="RCardnews W850" pitchFamily="34" charset="-127"/>
                 <a:ea typeface="RCardnews W850" pitchFamily="34" charset="-127"/>
                 <a:cs typeface="RCardnews W850" pitchFamily="34" charset="-127"/>
               </a:rPr>
-              <a:t xml:space="preserve">그래서 Aspetar는</a:t>
+              <a:t xml:space="preserve">착지</a:t>
+            </a:r>
+            <a:r>
+              <a:rPr lang="ko-KR" altLang="en-US" sz="6300" b="0" i="0" spc="-220" kern="0" dirty="0">
+                <a:solidFill>
+                  <a:srgbClr val="121416"/>
+                </a:solidFill>
+                <a:latin typeface="RCardnews W850" pitchFamily="34" charset="-127"/>
+                <a:ea typeface="RCardnews W850" pitchFamily="34" charset="-127"/>
+                <a:cs typeface="RCardnews W850" pitchFamily="34" charset="-127"/>
+              </a:rPr>
+              <a:t xml:space="preserve"> 때는 무릎이</a:t>
             </a:r>
             <a:endParaRPr lang="ko-KR" altLang="en-US" sz="6300" b="0" i="0" spc="-220" kern="0" dirty="0">
               <a:solidFill>
@@ -3411,14 +3717,14 @@
       </p:sp>
       <p:sp>
         <p:nvSpPr>
-          <p:cNvPr id="6" name="텍스트: 점프의 역학까지"/>
-          <p:cNvSpPr txBox="1"/>
-          <p:nvPr/>
-        </p:nvSpPr>
-        <p:spPr>
-          <a:xfrm>
-            <a:off x="1995636" y="1989171"/>
-            <a:ext cx="6295727" cy="962025"/>
+          <p:cNvPr id="16" name="텍스트: 가장 많이 받아냅니다"/>
+          <p:cNvSpPr txBox="1"/>
+          <p:nvPr/>
+        </p:nvSpPr>
+        <p:spPr>
+          <a:xfrm>
+            <a:off x="1189434" y="1989171"/>
+            <a:ext cx="7907982" cy="962025"/>
           </a:xfrm>
           <a:prstGeom prst="rect">
             <a:avLst/>
@@ -3449,24 +3755,13 @@
             <a:r>
               <a:rPr lang="ko-KR" altLang="en-US" sz="6300" b="0" i="0" spc="-220" kern="0" dirty="0">
                 <a:solidFill>
-                  <a:srgbClr val="0879D8"/>
+                  <a:srgbClr val="121416"/>
                 </a:solidFill>
                 <a:latin typeface="RCardnews W850" pitchFamily="34" charset="-127"/>
                 <a:ea typeface="RCardnews W850" pitchFamily="34" charset="-127"/>
                 <a:cs typeface="RCardnews W850" pitchFamily="34" charset="-127"/>
               </a:rPr>
-              <a:t xml:space="preserve">점프의 역학</a:t>
-            </a:r>
-            <a:r>
-              <a:rPr lang="ko-KR" altLang="en-US" sz="6300" b="0" i="0" spc="-220" kern="0" dirty="0">
-                <a:solidFill>
-                  <a:srgbClr val="121416"/>
-                </a:solidFill>
-                <a:latin typeface="RCardnews W850" pitchFamily="34" charset="-127"/>
-                <a:ea typeface="RCardnews W850" pitchFamily="34" charset="-127"/>
-                <a:cs typeface="RCardnews W850" pitchFamily="34" charset="-127"/>
-              </a:rPr>
-              <a:t xml:space="preserve">까지</a:t>
+              <a:t xml:space="preserve">가장 많이 받아냅니다</a:t>
             </a:r>
             <a:endParaRPr lang="ko-KR" altLang="en-US" sz="6300" b="0" i="0" spc="-220" kern="0" dirty="0">
               <a:solidFill>
@@ -3481,173 +3776,173 @@
       </p:sp>
       <p:sp>
         <p:nvSpPr>
-          <p:cNvPr id="7" name="텍스트: 살펴봅니다"/>
-          <p:cNvSpPr txBox="1"/>
-          <p:nvPr/>
-        </p:nvSpPr>
-        <p:spPr>
-          <a:xfrm>
-            <a:off x="2801689" y="2949261"/>
-            <a:ext cx="4683472" cy="962025"/>
-          </a:xfrm>
-          <a:prstGeom prst="rect">
-            <a:avLst/>
-          </a:prstGeom>
-          <a:noFill/>
-          <a:ln>
-            <a:noFill/>
-          </a:ln>
-        </p:spPr>
-        <p:txBody>
-          <a:bodyPr vert="horz" wrap="none" lIns="0" tIns="0" rIns="0" bIns="0" rtlCol="0" anchor="ctr" anchorCtr="0">
-            <a:noAutofit/>
-          </a:bodyPr>
-          <a:lstStyle/>
-          <a:p>
-            <a:pPr algn="ctr">
-              <a:lnSpc>
-                <a:spcPct val="100000"/>
-              </a:lnSpc>
-              <a:spcBef>
-                <a:spcPts val="0"/>
-              </a:spcBef>
-              <a:spcAft>
-                <a:spcPts val="0"/>
-              </a:spcAft>
-              <a:buNone/>
-            </a:pPr>
-            <a:r>
-              <a:rPr lang="ko-KR" altLang="en-US" sz="6300" b="0" i="0" spc="-220" kern="0" dirty="0">
+          <p:cNvPr id="17" name="텍스트: 무릎 몫: 도약 약 12% → 착지 약 65"/>
+          <p:cNvSpPr txBox="1"/>
+          <p:nvPr/>
+        </p:nvSpPr>
+        <p:spPr>
+          <a:xfrm>
+            <a:off x="1007418" y="3090612"/>
+            <a:ext cx="8272165" cy="552450"/>
+          </a:xfrm>
+          <a:prstGeom prst="rect">
+            <a:avLst/>
+          </a:prstGeom>
+          <a:noFill/>
+          <a:ln>
+            <a:noFill/>
+          </a:ln>
+        </p:spPr>
+        <p:txBody>
+          <a:bodyPr vert="horz" wrap="none" lIns="0" tIns="0" rIns="0" bIns="0" rtlCol="0" anchor="ctr" anchorCtr="0">
+            <a:noAutofit/>
+          </a:bodyPr>
+          <a:lstStyle/>
+          <a:p>
+            <a:pPr algn="ctr">
+              <a:lnSpc>
+                <a:spcPct val="100000"/>
+              </a:lnSpc>
+              <a:spcBef>
+                <a:spcPts val="0"/>
+              </a:spcBef>
+              <a:spcAft>
+                <a:spcPts val="0"/>
+              </a:spcAft>
+              <a:buNone/>
+            </a:pPr>
+            <a:r>
+              <a:rPr lang="ko-KR" altLang="en-US" sz="3600" b="0" i="0" spc="-72" kern="0" dirty="0">
                 <a:solidFill>
                   <a:srgbClr val="121416"/>
                 </a:solidFill>
-                <a:latin typeface="RCardnews W850" pitchFamily="34" charset="-127"/>
-                <a:ea typeface="RCardnews W850" pitchFamily="34" charset="-127"/>
-                <a:cs typeface="RCardnews W850" pitchFamily="34" charset="-127"/>
-              </a:rPr>
-              <a:t xml:space="preserve">살펴봅니다</a:t>
-            </a:r>
-            <a:endParaRPr lang="ko-KR" altLang="en-US" sz="6300" b="0" i="0" spc="-220" kern="0" dirty="0">
+                <a:latin typeface="RCardnews W650" pitchFamily="34" charset="-127"/>
+                <a:ea typeface="RCardnews W650" pitchFamily="34" charset="-127"/>
+                <a:cs typeface="RCardnews W650" pitchFamily="34" charset="-127"/>
+              </a:rPr>
+              <a:t xml:space="preserve">무릎 몫: 도약 약 12% → 착지 약 65%</a:t>
+            </a:r>
+            <a:endParaRPr lang="ko-KR" altLang="en-US" sz="3600" b="0" i="0" spc="-72" kern="0" dirty="0">
               <a:solidFill>
                 <a:srgbClr val="121416"/>
               </a:solidFill>
-              <a:latin typeface="RCardnews W850" pitchFamily="34" charset="-127"/>
-              <a:ea typeface="RCardnews W850" pitchFamily="34" charset="-127"/>
-              <a:cs typeface="RCardnews W850" pitchFamily="34" charset="-127"/>
-            </a:endParaRPr>
-          </a:p>
-        </p:txBody>
-      </p:sp>
-      <p:sp>
-        <p:nvSpPr>
-          <p:cNvPr id="8" name="텍스트: 각도 · 모멘트 · 일"/>
-          <p:cNvSpPr txBox="1"/>
-          <p:nvPr/>
-        </p:nvSpPr>
-        <p:spPr>
-          <a:xfrm>
-            <a:off x="2319486" y="8563237"/>
-            <a:ext cx="5648027" cy="733425"/>
-          </a:xfrm>
-          <a:prstGeom prst="rect">
-            <a:avLst/>
-          </a:prstGeom>
-          <a:noFill/>
-          <a:ln>
-            <a:noFill/>
-          </a:ln>
-        </p:spPr>
-        <p:txBody>
-          <a:bodyPr vert="horz" wrap="none" lIns="0" tIns="0" rIns="0" bIns="0" rtlCol="0" anchor="ctr" anchorCtr="0">
-            <a:noAutofit/>
-          </a:bodyPr>
-          <a:lstStyle/>
-          <a:p>
-            <a:pPr algn="ctr">
-              <a:lnSpc>
-                <a:spcPct val="100000"/>
-              </a:lnSpc>
-              <a:spcBef>
-                <a:spcPts val="0"/>
-              </a:spcBef>
-              <a:spcAft>
-                <a:spcPts val="0"/>
-              </a:spcAft>
-              <a:buNone/>
-            </a:pPr>
-            <a:r>
-              <a:rPr lang="ko-KR" altLang="en-US" sz="4800" b="0" i="0" spc="-144" kern="0" dirty="0">
-                <a:solidFill>
-                  <a:srgbClr val="0879D8"/>
-                </a:solidFill>
-                <a:latin typeface="RCardnews W850" pitchFamily="34" charset="-127"/>
-                <a:ea typeface="RCardnews W850" pitchFamily="34" charset="-127"/>
-                <a:cs typeface="RCardnews W850" pitchFamily="34" charset="-127"/>
-              </a:rPr>
-              <a:t xml:space="preserve">각도 · 모멘트 · 일</a:t>
-            </a:r>
-            <a:endParaRPr lang="ko-KR" altLang="en-US" sz="4800" b="0" i="0" spc="-144" kern="0" dirty="0">
-              <a:solidFill>
-                <a:srgbClr val="0879D8"/>
-              </a:solidFill>
-              <a:latin typeface="RCardnews W850" pitchFamily="34" charset="-127"/>
-              <a:ea typeface="RCardnews W850" pitchFamily="34" charset="-127"/>
-              <a:cs typeface="RCardnews W850" pitchFamily="34" charset="-127"/>
-            </a:endParaRPr>
-          </a:p>
-        </p:txBody>
-      </p:sp>
-      <p:sp>
-        <p:nvSpPr>
-          <p:cNvPr id="9" name="텍스트: 수직·수평 점프에서 고관절·무릎·발목의"/>
-          <p:cNvSpPr txBox="1"/>
-          <p:nvPr/>
-        </p:nvSpPr>
-        <p:spPr>
-          <a:xfrm>
-            <a:off x="1097161" y="9445222"/>
-            <a:ext cx="8092529" cy="504825"/>
-          </a:xfrm>
-          <a:prstGeom prst="rect">
-            <a:avLst/>
-          </a:prstGeom>
-          <a:noFill/>
-          <a:ln>
-            <a:noFill/>
-          </a:ln>
-        </p:spPr>
-        <p:txBody>
-          <a:bodyPr vert="horz" wrap="none" lIns="0" tIns="0" rIns="0" bIns="0" rtlCol="0" anchor="ctr" anchorCtr="0">
-            <a:noAutofit/>
-          </a:bodyPr>
-          <a:lstStyle/>
-          <a:p>
-            <a:pPr algn="ctr">
-              <a:lnSpc>
-                <a:spcPct val="100000"/>
-              </a:lnSpc>
-              <a:spcBef>
-                <a:spcPts val="0"/>
-              </a:spcBef>
-              <a:spcAft>
-                <a:spcPts val="0"/>
-              </a:spcAft>
-              <a:buNone/>
-            </a:pPr>
-            <a:r>
-              <a:rPr lang="ko-KR" altLang="en-US" sz="3300" b="0" i="0" spc="-66" kern="0" dirty="0">
-                <a:solidFill>
-                  <a:srgbClr val="121416"/>
+              <a:latin typeface="RCardnews W650" pitchFamily="34" charset="-127"/>
+              <a:ea typeface="RCardnews W650" pitchFamily="34" charset="-127"/>
+              <a:cs typeface="RCardnews W650" pitchFamily="34" charset="-127"/>
+            </a:endParaRPr>
+          </a:p>
+        </p:txBody>
+      </p:sp>
+      <p:sp>
+        <p:nvSpPr>
+          <p:cNvPr id="18" name="텍스트: 착지 기여율"/>
+          <p:cNvSpPr txBox="1"/>
+          <p:nvPr/>
+        </p:nvSpPr>
+        <p:spPr>
+          <a:xfrm>
+            <a:off x="760214" y="3897100"/>
+            <a:ext cx="2775347" cy="409575"/>
+          </a:xfrm>
+          <a:prstGeom prst="rect">
+            <a:avLst/>
+          </a:prstGeom>
+          <a:noFill/>
+          <a:ln>
+            <a:noFill/>
+          </a:ln>
+        </p:spPr>
+        <p:txBody>
+          <a:bodyPr vert="horz" wrap="none" lIns="0" tIns="0" rIns="0" bIns="0" rtlCol="0" anchor="ctr" anchorCtr="0">
+            <a:noAutofit/>
+          </a:bodyPr>
+          <a:lstStyle/>
+          <a:p>
+            <a:pPr algn="ctr">
+              <a:lnSpc>
+                <a:spcPct val="100000"/>
+              </a:lnSpc>
+              <a:spcBef>
+                <a:spcPts val="0"/>
+              </a:spcBef>
+              <a:spcAft>
+                <a:spcPts val="0"/>
+              </a:spcAft>
+              <a:buNone/>
+            </a:pPr>
+            <a:r>
+              <a:rPr lang="ko-KR" altLang="en-US" sz="2700" b="0" i="0" spc="-54" kern="0" dirty="0">
+                <a:solidFill>
+                  <a:srgbClr val="5E6570"/>
+                </a:solidFill>
+                <a:latin typeface="RCardnews W650" pitchFamily="34" charset="-127"/>
+                <a:ea typeface="RCardnews W650" pitchFamily="34" charset="-127"/>
+                <a:cs typeface="RCardnews W650" pitchFamily="34" charset="-127"/>
+              </a:rPr>
+              <a:t xml:space="preserve">착지 기여율</a:t>
+            </a:r>
+            <a:endParaRPr lang="ko-KR" altLang="en-US" sz="2700" b="0" i="0" spc="-54" kern="0" dirty="0">
+              <a:solidFill>
+                <a:srgbClr val="5E6570"/>
+              </a:solidFill>
+              <a:latin typeface="RCardnews W650" pitchFamily="34" charset="-127"/>
+              <a:ea typeface="RCardnews W650" pitchFamily="34" charset="-127"/>
+              <a:cs typeface="RCardnews W650" pitchFamily="34" charset="-127"/>
+            </a:endParaRPr>
+          </a:p>
+        </p:txBody>
+      </p:sp>
+      <p:sp>
+        <p:nvSpPr>
+          <p:cNvPr id="19" name="텍스트: Figure 3"/>
+          <p:cNvSpPr txBox="1"/>
+          <p:nvPr/>
+        </p:nvSpPr>
+        <p:spPr>
+          <a:xfrm>
+            <a:off x="941636" y="9096708"/>
+            <a:ext cx="2412355" cy="409575"/>
+          </a:xfrm>
+          <a:prstGeom prst="rect">
+            <a:avLst/>
+          </a:prstGeom>
+          <a:noFill/>
+          <a:ln>
+            <a:noFill/>
+          </a:ln>
+        </p:spPr>
+        <p:txBody>
+          <a:bodyPr vert="horz" wrap="none" lIns="0" tIns="0" rIns="0" bIns="0" rtlCol="0" anchor="ctr" anchorCtr="0">
+            <a:noAutofit/>
+          </a:bodyPr>
+          <a:lstStyle/>
+          <a:p>
+            <a:pPr algn="ctr">
+              <a:lnSpc>
+                <a:spcPct val="100000"/>
+              </a:lnSpc>
+              <a:spcBef>
+                <a:spcPts val="0"/>
+              </a:spcBef>
+              <a:spcAft>
+                <a:spcPts val="0"/>
+              </a:spcAft>
+              <a:buNone/>
+            </a:pPr>
+            <a:r>
+              <a:rPr lang="ko-KR" altLang="en-US" sz="2700" b="0" i="0" spc="-54" kern="0" dirty="0">
+                <a:solidFill>
+                  <a:srgbClr val="5E6570"/>
                 </a:solidFill>
                 <a:latin typeface="RCardnews W500" pitchFamily="34" charset="-127"/>
                 <a:ea typeface="RCardnews W500" pitchFamily="34" charset="-127"/>
                 <a:cs typeface="RCardnews W500" pitchFamily="34" charset="-127"/>
               </a:rPr>
-              <a:t xml:space="preserve">수직·수평 점프에서 고관절·무릎·발목의</a:t>
-            </a:r>
-            <a:endParaRPr lang="ko-KR" altLang="en-US" sz="3300" b="0" i="0" spc="-66" kern="0" dirty="0">
-              <a:solidFill>
-                <a:srgbClr val="121416"/>
+              <a:t xml:space="preserve">Figure 3</a:t>
+            </a:r>
+            <a:endParaRPr lang="ko-KR" altLang="en-US" sz="2700" b="0" i="0" spc="-54" kern="0" dirty="0">
+              <a:solidFill>
+                <a:srgbClr val="5E6570"/>
               </a:solidFill>
               <a:latin typeface="RCardnews W500" pitchFamily="34" charset="-127"/>
               <a:ea typeface="RCardnews W500" pitchFamily="34" charset="-127"/>
@@ -3658,55 +3953,232 @@
       </p:sp>
       <p:sp>
         <p:nvSpPr>
-          <p:cNvPr id="10" name="텍스트: 절대값과 좌우 대칭을 모두 정상 수준으로"/>
-          <p:cNvSpPr txBox="1"/>
-          <p:nvPr/>
-        </p:nvSpPr>
-        <p:spPr>
-          <a:xfrm>
-            <a:off x="1093440" y="10040237"/>
-            <a:ext cx="8100120" cy="504825"/>
-          </a:xfrm>
-          <a:prstGeom prst="rect">
-            <a:avLst/>
-          </a:prstGeom>
-          <a:noFill/>
-          <a:ln>
-            <a:noFill/>
-          </a:ln>
-        </p:spPr>
-        <p:txBody>
-          <a:bodyPr vert="horz" wrap="none" lIns="0" tIns="0" rIns="0" bIns="0" rtlCol="0" anchor="ctr" anchorCtr="0">
-            <a:noAutofit/>
-          </a:bodyPr>
-          <a:lstStyle/>
-          <a:p>
-            <a:pPr algn="ctr">
-              <a:lnSpc>
-                <a:spcPct val="100000"/>
-              </a:lnSpc>
-              <a:spcBef>
-                <a:spcPts val="0"/>
-              </a:spcBef>
-              <a:spcAft>
-                <a:spcPts val="0"/>
-              </a:spcAft>
-              <a:buNone/>
-            </a:pPr>
-            <a:r>
-              <a:rPr lang="ko-KR" altLang="en-US" sz="3300" b="0" i="0" spc="-66" kern="0" dirty="0">
-                <a:solidFill>
-                  <a:srgbClr val="121416"/>
+          <p:cNvPr id="20" name="텍스트: 수술측"/>
+          <p:cNvSpPr txBox="1"/>
+          <p:nvPr/>
+        </p:nvSpPr>
+        <p:spPr>
+          <a:xfrm>
+            <a:off x="4554736" y="3897100"/>
+            <a:ext cx="2068860" cy="409575"/>
+          </a:xfrm>
+          <a:prstGeom prst="rect">
+            <a:avLst/>
+          </a:prstGeom>
+          <a:noFill/>
+          <a:ln>
+            <a:noFill/>
+          </a:ln>
+        </p:spPr>
+        <p:txBody>
+          <a:bodyPr vert="horz" wrap="none" lIns="0" tIns="0" rIns="0" bIns="0" rtlCol="0" anchor="ctr" anchorCtr="0">
+            <a:noAutofit/>
+          </a:bodyPr>
+          <a:lstStyle/>
+          <a:p>
+            <a:pPr algn="ctr">
+              <a:lnSpc>
+                <a:spcPct val="100000"/>
+              </a:lnSpc>
+              <a:spcBef>
+                <a:spcPts val="0"/>
+              </a:spcBef>
+              <a:spcAft>
+                <a:spcPts val="0"/>
+              </a:spcAft>
+              <a:buNone/>
+            </a:pPr>
+            <a:r>
+              <a:rPr lang="ko-KR" altLang="en-US" sz="2700" b="0" i="0" spc="-54" kern="0" dirty="0">
+                <a:solidFill>
+                  <a:srgbClr val="CC414A"/>
+                </a:solidFill>
+                <a:latin typeface="RCardnews W650" pitchFamily="34" charset="-127"/>
+                <a:ea typeface="RCardnews W650" pitchFamily="34" charset="-127"/>
+                <a:cs typeface="RCardnews W650" pitchFamily="34" charset="-127"/>
+              </a:rPr>
+              <a:t xml:space="preserve">수술측</a:t>
+            </a:r>
+            <a:endParaRPr lang="ko-KR" altLang="en-US" sz="2700" b="0" i="0" spc="-54" kern="0" dirty="0">
+              <a:solidFill>
+                <a:srgbClr val="CC414A"/>
+              </a:solidFill>
+              <a:latin typeface="RCardnews W650" pitchFamily="34" charset="-127"/>
+              <a:ea typeface="RCardnews W650" pitchFamily="34" charset="-127"/>
+              <a:cs typeface="RCardnews W650" pitchFamily="34" charset="-127"/>
+            </a:endParaRPr>
+          </a:p>
+        </p:txBody>
+      </p:sp>
+      <p:sp>
+        <p:nvSpPr>
+          <p:cNvPr id="21" name="텍스트: 비수술측"/>
+          <p:cNvSpPr txBox="1"/>
+          <p:nvPr/>
+        </p:nvSpPr>
+        <p:spPr>
+          <a:xfrm>
+            <a:off x="5615732" y="3897100"/>
+            <a:ext cx="2377529" cy="409575"/>
+          </a:xfrm>
+          <a:prstGeom prst="rect">
+            <a:avLst/>
+          </a:prstGeom>
+          <a:noFill/>
+          <a:ln>
+            <a:noFill/>
+          </a:ln>
+        </p:spPr>
+        <p:txBody>
+          <a:bodyPr vert="horz" wrap="none" lIns="0" tIns="0" rIns="0" bIns="0" rtlCol="0" anchor="ctr" anchorCtr="0">
+            <a:noAutofit/>
+          </a:bodyPr>
+          <a:lstStyle/>
+          <a:p>
+            <a:pPr algn="ctr">
+              <a:lnSpc>
+                <a:spcPct val="100000"/>
+              </a:lnSpc>
+              <a:spcBef>
+                <a:spcPts val="0"/>
+              </a:spcBef>
+              <a:spcAft>
+                <a:spcPts val="0"/>
+              </a:spcAft>
+              <a:buNone/>
+            </a:pPr>
+            <a:r>
+              <a:rPr lang="ko-KR" altLang="en-US" sz="2700" b="0" i="0" spc="-54" kern="0" dirty="0">
+                <a:solidFill>
+                  <a:srgbClr val="0879D8"/>
+                </a:solidFill>
+                <a:latin typeface="RCardnews W650" pitchFamily="34" charset="-127"/>
+                <a:ea typeface="RCardnews W650" pitchFamily="34" charset="-127"/>
+                <a:cs typeface="RCardnews W650" pitchFamily="34" charset="-127"/>
+              </a:rPr>
+              <a:t xml:space="preserve">비수술측</a:t>
+            </a:r>
+            <a:endParaRPr lang="ko-KR" altLang="en-US" sz="2700" b="0" i="0" spc="-54" kern="0" dirty="0">
+              <a:solidFill>
+                <a:srgbClr val="0879D8"/>
+              </a:solidFill>
+              <a:latin typeface="RCardnews W650" pitchFamily="34" charset="-127"/>
+              <a:ea typeface="RCardnews W650" pitchFamily="34" charset="-127"/>
+              <a:cs typeface="RCardnews W650" pitchFamily="34" charset="-127"/>
+            </a:endParaRPr>
+          </a:p>
+        </p:txBody>
+      </p:sp>
+      <p:sp>
+        <p:nvSpPr>
+          <p:cNvPr id="22" name="텍스트: 대조군"/>
+          <p:cNvSpPr txBox="1"/>
+          <p:nvPr/>
+        </p:nvSpPr>
+        <p:spPr>
+          <a:xfrm>
+            <a:off x="7330232" y="3897100"/>
+            <a:ext cx="2068860" cy="409575"/>
+          </a:xfrm>
+          <a:prstGeom prst="rect">
+            <a:avLst/>
+          </a:prstGeom>
+          <a:noFill/>
+          <a:ln>
+            <a:noFill/>
+          </a:ln>
+        </p:spPr>
+        <p:txBody>
+          <a:bodyPr vert="horz" wrap="none" lIns="0" tIns="0" rIns="0" bIns="0" rtlCol="0" anchor="ctr" anchorCtr="0">
+            <a:noAutofit/>
+          </a:bodyPr>
+          <a:lstStyle/>
+          <a:p>
+            <a:pPr algn="ctr">
+              <a:lnSpc>
+                <a:spcPct val="100000"/>
+              </a:lnSpc>
+              <a:spcBef>
+                <a:spcPts val="0"/>
+              </a:spcBef>
+              <a:spcAft>
+                <a:spcPts val="0"/>
+              </a:spcAft>
+              <a:buNone/>
+            </a:pPr>
+            <a:r>
+              <a:rPr lang="ko-KR" altLang="en-US" sz="2700" b="0" i="0" spc="-54" kern="0" dirty="0">
+                <a:solidFill>
+                  <a:srgbClr val="7D858D"/>
+                </a:solidFill>
+                <a:latin typeface="RCardnews W650" pitchFamily="34" charset="-127"/>
+                <a:ea typeface="RCardnews W650" pitchFamily="34" charset="-127"/>
+                <a:cs typeface="RCardnews W650" pitchFamily="34" charset="-127"/>
+              </a:rPr>
+              <a:t xml:space="preserve">대조군</a:t>
+            </a:r>
+            <a:endParaRPr lang="ko-KR" altLang="en-US" sz="2700" b="0" i="0" spc="-54" kern="0" dirty="0">
+              <a:solidFill>
+                <a:srgbClr val="7D858D"/>
+              </a:solidFill>
+              <a:latin typeface="RCardnews W650" pitchFamily="34" charset="-127"/>
+              <a:ea typeface="RCardnews W650" pitchFamily="34" charset="-127"/>
+              <a:cs typeface="RCardnews W650" pitchFamily="34" charset="-127"/>
+            </a:endParaRPr>
+          </a:p>
+        </p:txBody>
+      </p:sp>
+      <p:sp>
+        <p:nvSpPr>
+          <p:cNvPr id="23" name="텍스트: Figure 2 · 착지 때 받아낸 일(J/"/>
+          <p:cNvSpPr txBox="1"/>
+          <p:nvPr/>
+        </p:nvSpPr>
+        <p:spPr>
+          <a:xfrm>
+            <a:off x="3442990" y="9098643"/>
+            <a:ext cx="6029771" cy="409575"/>
+          </a:xfrm>
+          <a:prstGeom prst="rect">
+            <a:avLst/>
+          </a:prstGeom>
+          <a:noFill/>
+          <a:ln>
+            <a:noFill/>
+          </a:ln>
+        </p:spPr>
+        <p:txBody>
+          <a:bodyPr vert="horz" wrap="none" lIns="0" tIns="0" rIns="0" bIns="0" rtlCol="0" anchor="ctr" anchorCtr="0">
+            <a:noAutofit/>
+          </a:bodyPr>
+          <a:lstStyle/>
+          <a:p>
+            <a:pPr algn="ctr">
+              <a:lnSpc>
+                <a:spcPct val="100000"/>
+              </a:lnSpc>
+              <a:spcBef>
+                <a:spcPts val="0"/>
+              </a:spcBef>
+              <a:spcAft>
+                <a:spcPts val="0"/>
+              </a:spcAft>
+              <a:buNone/>
+            </a:pPr>
+            <a:r>
+              <a:rPr lang="ko-KR" altLang="en-US" sz="2700" b="0" i="0" spc="-54" kern="0" dirty="0">
+                <a:solidFill>
+                  <a:srgbClr val="5E6570"/>
                 </a:solidFill>
                 <a:latin typeface="RCardnews W500" pitchFamily="34" charset="-127"/>
                 <a:ea typeface="RCardnews W500" pitchFamily="34" charset="-127"/>
                 <a:cs typeface="RCardnews W500" pitchFamily="34" charset="-127"/>
               </a:rPr>
-              <a:t xml:space="preserve">절대값과 좌우 대칭을 모두 정상 수준으로</a:t>
-            </a:r>
-            <a:endParaRPr lang="ko-KR" altLang="en-US" sz="3300" b="0" i="0" spc="-66" kern="0" dirty="0">
-              <a:solidFill>
-                <a:srgbClr val="121416"/>
+              <a:t xml:space="preserve">Figure 2 · 착지 때 받아낸 일(J/kg)</a:t>
+            </a:r>
+            <a:endParaRPr lang="ko-KR" altLang="en-US" sz="2700" b="0" i="0" spc="-54" kern="0" dirty="0">
+              <a:solidFill>
+                <a:srgbClr val="5E6570"/>
               </a:solidFill>
               <a:latin typeface="RCardnews W500" pitchFamily="34" charset="-127"/>
               <a:ea typeface="RCardnews W500" pitchFamily="34" charset="-127"/>
@@ -3717,55 +4189,77 @@
       </p:sp>
       <p:sp>
         <p:nvSpPr>
-          <p:cNvPr id="11" name="텍스트: 전문 선수의 복귀 평가를 위한 제안이며,"/>
-          <p:cNvSpPr txBox="1"/>
-          <p:nvPr/>
-        </p:nvSpPr>
-        <p:spPr>
-          <a:xfrm>
-            <a:off x="1832372" y="10887855"/>
-            <a:ext cx="6622256" cy="409575"/>
-          </a:xfrm>
-          <a:prstGeom prst="rect">
-            <a:avLst/>
-          </a:prstGeom>
-          <a:noFill/>
-          <a:ln>
-            <a:noFill/>
-          </a:ln>
-        </p:spPr>
-        <p:txBody>
-          <a:bodyPr vert="horz" wrap="none" lIns="0" tIns="0" rIns="0" bIns="0" rtlCol="0" anchor="ctr" anchorCtr="0">
-            <a:noAutofit/>
-          </a:bodyPr>
-          <a:lstStyle/>
-          <a:p>
-            <a:pPr algn="ctr">
-              <a:lnSpc>
-                <a:spcPct val="100000"/>
-              </a:lnSpc>
-              <a:spcBef>
-                <a:spcPts val="0"/>
-              </a:spcBef>
-              <a:spcAft>
-                <a:spcPts val="0"/>
-              </a:spcAft>
-              <a:buNone/>
-            </a:pPr>
-            <a:r>
-              <a:rPr lang="ko-KR" altLang="en-US" sz="2700" b="0" i="0" spc="-54" kern="0" dirty="0">
-                <a:solidFill>
-                  <a:srgbClr val="5E6570"/>
+          <p:cNvPr id="24" name="텍스트: 수술측 무릎은 반대쪽보다 덜 받아내고,"/>
+          <p:cNvSpPr txBox="1"/>
+          <p:nvPr/>
+        </p:nvSpPr>
+        <p:spPr>
+          <a:xfrm>
+            <a:off x="1277838" y="9821311"/>
+            <a:ext cx="7731026" cy="504825"/>
+          </a:xfrm>
+          <a:prstGeom prst="rect">
+            <a:avLst/>
+          </a:prstGeom>
+          <a:noFill/>
+          <a:ln>
+            <a:noFill/>
+          </a:ln>
+        </p:spPr>
+        <p:txBody>
+          <a:bodyPr vert="horz" wrap="none" lIns="0" tIns="0" rIns="0" bIns="0" rtlCol="0" anchor="ctr" anchorCtr="0">
+            <a:noAutofit/>
+          </a:bodyPr>
+          <a:lstStyle/>
+          <a:p>
+            <a:pPr algn="ctr">
+              <a:lnSpc>
+                <a:spcPct val="100000"/>
+              </a:lnSpc>
+              <a:spcBef>
+                <a:spcPts val="0"/>
+              </a:spcBef>
+              <a:spcAft>
+                <a:spcPts val="0"/>
+              </a:spcAft>
+              <a:buNone/>
+            </a:pPr>
+            <a:r>
+              <a:rPr lang="ko-KR" altLang="en-US" sz="3300" b="0" i="0" spc="-66" kern="0" dirty="0">
+                <a:solidFill>
+                  <a:srgbClr val="121416"/>
                 </a:solidFill>
                 <a:latin typeface="RCardnews W500" pitchFamily="34" charset="-127"/>
                 <a:ea typeface="RCardnews W500" pitchFamily="34" charset="-127"/>
                 <a:cs typeface="RCardnews W500" pitchFamily="34" charset="-127"/>
               </a:rPr>
-              <a:t xml:space="preserve">전문 선수의 복귀 평가를 위한 제안이며,</a:t>
-            </a:r>
-            <a:endParaRPr lang="ko-KR" altLang="en-US" sz="2700" b="0" i="0" spc="-54" kern="0" dirty="0">
-              <a:solidFill>
-                <a:srgbClr val="5E6570"/>
+              <a:t xml:space="preserve">수술측 무릎은 반대쪽보다 </a:t>
+            </a:r>
+            <a:r>
+              <a:rPr lang="ko-KR" altLang="en-US" sz="3300" b="0" i="0" spc="-66" kern="0" dirty="0">
+                <a:solidFill>
+                  <a:srgbClr val="121416"/>
+                </a:solidFill>
+                <a:latin typeface="RCardnews W750" pitchFamily="34" charset="-127"/>
+                <a:ea typeface="RCardnews W750" pitchFamily="34" charset="-127"/>
+                <a:cs typeface="RCardnews W750" pitchFamily="34" charset="-127"/>
+              </a:rPr>
+              <a:t xml:space="preserve">덜</a:t>
+            </a:r>
+            <a:r>
+              <a:rPr lang="ko-KR" altLang="en-US" sz="3300" b="0" i="0" spc="-66" kern="0" dirty="0">
+                <a:solidFill>
+                  <a:srgbClr val="121416"/>
+                </a:solidFill>
+                <a:latin typeface="RCardnews W500" pitchFamily="34" charset="-127"/>
+                <a:ea typeface="RCardnews W500" pitchFamily="34" charset="-127"/>
+                <a:cs typeface="RCardnews W500" pitchFamily="34" charset="-127"/>
+              </a:rPr>
+              <a:t xml:space="preserve"> 받아내고,</a:t>
+            </a:r>
+            <a:endParaRPr lang="ko-KR" altLang="en-US" sz="3300" b="0" i="0" spc="-66" kern="0" dirty="0">
+              <a:solidFill>
+                <a:srgbClr val="121416"/>
               </a:solidFill>
               <a:latin typeface="RCardnews W500" pitchFamily="34" charset="-127"/>
               <a:ea typeface="RCardnews W500" pitchFamily="34" charset="-127"/>
@@ -3776,51 +4270,132 @@
       </p:sp>
       <p:sp>
         <p:nvSpPr>
-          <p:cNvPr id="12" name="텍스트: 재부상 예방이 검증된 기준은 아닙니다."/>
-          <p:cNvSpPr txBox="1"/>
-          <p:nvPr/>
-        </p:nvSpPr>
-        <p:spPr>
-          <a:xfrm>
-            <a:off x="1876871" y="11367826"/>
-            <a:ext cx="6533108" cy="409575"/>
-          </a:xfrm>
-          <a:prstGeom prst="rect">
-            <a:avLst/>
-          </a:prstGeom>
-          <a:noFill/>
-          <a:ln>
-            <a:noFill/>
-          </a:ln>
-        </p:spPr>
-        <p:txBody>
-          <a:bodyPr vert="horz" wrap="none" lIns="0" tIns="0" rIns="0" bIns="0" rtlCol="0" anchor="ctr" anchorCtr="0">
-            <a:noAutofit/>
-          </a:bodyPr>
-          <a:lstStyle/>
-          <a:p>
-            <a:pPr algn="ctr">
-              <a:lnSpc>
-                <a:spcPct val="100000"/>
-              </a:lnSpc>
-              <a:spcBef>
-                <a:spcPts val="0"/>
-              </a:spcBef>
-              <a:spcAft>
-                <a:spcPts val="0"/>
-              </a:spcAft>
-              <a:buNone/>
-            </a:pPr>
-            <a:r>
-              <a:rPr lang="ko-KR" altLang="en-US" sz="2700" b="0" i="0" spc="-54" kern="0" dirty="0">
-                <a:solidFill>
-                  <a:srgbClr val="5E6570"/>
+          <p:cNvPr id="25" name="텍스트: 반대쪽 무릎은 대조군보다 더 받아냈습니다."/>
+          <p:cNvSpPr txBox="1"/>
+          <p:nvPr/>
+        </p:nvSpPr>
+        <p:spPr>
+          <a:xfrm>
+            <a:off x="900708" y="10416326"/>
+            <a:ext cx="8485436" cy="504825"/>
+          </a:xfrm>
+          <a:prstGeom prst="rect">
+            <a:avLst/>
+          </a:prstGeom>
+          <a:noFill/>
+          <a:ln>
+            <a:noFill/>
+          </a:ln>
+        </p:spPr>
+        <p:txBody>
+          <a:bodyPr vert="horz" wrap="none" lIns="0" tIns="0" rIns="0" bIns="0" rtlCol="0" anchor="ctr" anchorCtr="0">
+            <a:noAutofit/>
+          </a:bodyPr>
+          <a:lstStyle/>
+          <a:p>
+            <a:pPr algn="ctr">
+              <a:lnSpc>
+                <a:spcPct val="100000"/>
+              </a:lnSpc>
+              <a:spcBef>
+                <a:spcPts val="0"/>
+              </a:spcBef>
+              <a:spcAft>
+                <a:spcPts val="0"/>
+              </a:spcAft>
+              <a:buNone/>
+            </a:pPr>
+            <a:r>
+              <a:rPr lang="ko-KR" altLang="en-US" sz="3300" b="0" i="0" spc="-66" kern="0" dirty="0">
+                <a:solidFill>
+                  <a:srgbClr val="121416"/>
                 </a:solidFill>
                 <a:latin typeface="RCardnews W500" pitchFamily="34" charset="-127"/>
                 <a:ea typeface="RCardnews W500" pitchFamily="34" charset="-127"/>
                 <a:cs typeface="RCardnews W500" pitchFamily="34" charset="-127"/>
               </a:rPr>
-              <a:t xml:space="preserve">재부상 예방이 검증된 기준은 아닙니다.</a:t>
+              <a:t xml:space="preserve">반대쪽 무릎은 대조군보다 </a:t>
+            </a:r>
+            <a:r>
+              <a:rPr lang="ko-KR" altLang="en-US" sz="3300" b="0" i="0" spc="-66" kern="0" dirty="0">
+                <a:solidFill>
+                  <a:srgbClr val="121416"/>
+                </a:solidFill>
+                <a:latin typeface="RCardnews W750" pitchFamily="34" charset="-127"/>
+                <a:ea typeface="RCardnews W750" pitchFamily="34" charset="-127"/>
+                <a:cs typeface="RCardnews W750" pitchFamily="34" charset="-127"/>
+              </a:rPr>
+              <a:t xml:space="preserve">더</a:t>
+            </a:r>
+            <a:r>
+              <a:rPr lang="ko-KR" altLang="en-US" sz="3300" b="0" i="0" spc="-66" kern="0" dirty="0">
+                <a:solidFill>
+                  <a:srgbClr val="121416"/>
+                </a:solidFill>
+                <a:latin typeface="RCardnews W500" pitchFamily="34" charset="-127"/>
+                <a:ea typeface="RCardnews W500" pitchFamily="34" charset="-127"/>
+                <a:cs typeface="RCardnews W500" pitchFamily="34" charset="-127"/>
+              </a:rPr>
+              <a:t xml:space="preserve"> 받아냈습니다.</a:t>
+            </a:r>
+            <a:endParaRPr lang="ko-KR" altLang="en-US" sz="3300" b="0" i="0" spc="-66" kern="0" dirty="0">
+              <a:solidFill>
+                <a:srgbClr val="121416"/>
+              </a:solidFill>
+              <a:latin typeface="RCardnews W500" pitchFamily="34" charset="-127"/>
+              <a:ea typeface="RCardnews W500" pitchFamily="34" charset="-127"/>
+              <a:cs typeface="RCardnews W500" pitchFamily="34" charset="-127"/>
+            </a:endParaRPr>
+          </a:p>
+        </p:txBody>
+      </p:sp>
+      <p:sp>
+        <p:nvSpPr>
+          <p:cNvPr id="26" name="텍스트: 수술측은 고관절 몫을 늘리고 몸통을 더 숙여"/>
+          <p:cNvSpPr txBox="1"/>
+          <p:nvPr/>
+        </p:nvSpPr>
+        <p:spPr>
+          <a:xfrm>
+            <a:off x="556617" y="11092494"/>
+            <a:ext cx="9173766" cy="409575"/>
+          </a:xfrm>
+          <a:prstGeom prst="rect">
+            <a:avLst/>
+          </a:prstGeom>
+          <a:noFill/>
+          <a:ln>
+            <a:noFill/>
+          </a:ln>
+        </p:spPr>
+        <p:txBody>
+          <a:bodyPr vert="horz" wrap="none" lIns="0" tIns="0" rIns="0" bIns="0" rtlCol="0" anchor="ctr" anchorCtr="0">
+            <a:noAutofit/>
+          </a:bodyPr>
+          <a:lstStyle/>
+          <a:p>
+            <a:pPr algn="ctr">
+              <a:lnSpc>
+                <a:spcPct val="100000"/>
+              </a:lnSpc>
+              <a:spcBef>
+                <a:spcPts val="0"/>
+              </a:spcBef>
+              <a:spcAft>
+                <a:spcPts val="0"/>
+              </a:spcAft>
+              <a:buNone/>
+            </a:pPr>
+            <a:r>
+              <a:rPr lang="ko-KR" altLang="en-US" sz="2700" b="0" i="0" spc="-54" kern="0" dirty="0">
+                <a:solidFill>
+                  <a:srgbClr val="5E6570"/>
+                </a:solidFill>
+                <a:latin typeface="RCardnews W500" pitchFamily="34" charset="-127"/>
+                <a:ea typeface="RCardnews W500" pitchFamily="34" charset="-127"/>
+                <a:cs typeface="RCardnews W500" pitchFamily="34" charset="-127"/>
+              </a:rPr>
+              <a:t xml:space="preserve">수술측은 고관절 몫을 늘리고 몸통을 더 숙여 착지했습니다</a:t>
             </a:r>
             <a:endParaRPr lang="ko-KR" altLang="en-US" sz="2700" b="0" i="0" spc="-54" kern="0" dirty="0">
               <a:solidFill>
@@ -3842,6 +4417,601 @@
 </file>
 
 <file path=ppt/slides/slide6.xml><?xml version="1.0" encoding="utf-8"?>
+<p:sld xmlns:a="http://schemas.openxmlformats.org/drawingml/2006/main" xmlns:r="http://schemas.openxmlformats.org/officeDocument/2006/relationships" xmlns:p="http://schemas.openxmlformats.org/presentationml/2006/main">
+  <p:cSld>
+    <p:bg>
+      <p:bgPr>
+        <a:solidFill>
+          <a:srgbClr val="FFFFFF"/>
+        </a:solidFill>
+        <a:effectLst/>
+      </p:bgPr>
+    </p:bg>
+    <p:spTree>
+      <p:nvGrpSpPr>
+        <p:cNvPr id="1" name=""/>
+        <p:cNvGrpSpPr/>
+        <p:nvPr/>
+      </p:nvGrpSpPr>
+      <p:grpSpPr>
+        <a:xfrm>
+          <a:off x="0" y="0"/>
+          <a:ext cx="0" cy="0"/>
+          <a:chOff x="0" y="0"/>
+          <a:chExt cx="0" cy="0"/>
+        </a:xfrm>
+      </p:grpSpPr>
+      <p:pic>
+        <p:nvPicPr>
+          <p:cNvPr id="2" name="사진" descr="Aspetar 2023 가이드라인 Box 5 스포츠 복귀 최소 기준 머리글 원문"/>
+          <p:cNvPicPr>
+            <a:picLocks noChangeAspect="1"/>
+          </p:cNvPicPr>
+          <p:nvPr/>
+        </p:nvPicPr>
+        <p:blipFill>
+          <a:blip r:embed="rId2"/>
+          <a:stretch>
+            <a:fillRect/>
+          </a:stretch>
+        </p:blipFill>
+        <p:spPr>
+          <a:xfrm>
+            <a:off x="1143000" y="4175671"/>
+            <a:ext cx="8001000" cy="2595562"/>
+          </a:xfrm>
+          <a:prstGeom prst="rect">
+            <a:avLst/>
+          </a:prstGeom>
+        </p:spPr>
+      </p:pic>
+      <p:pic>
+        <p:nvPicPr>
+          <p:cNvPr id="3" name="사진" descr="Aspetar 2023 가이드라인 Box 5 Jumping biomechanics 원문"/>
+          <p:cNvPicPr>
+            <a:picLocks noChangeAspect="1"/>
+          </p:cNvPicPr>
+          <p:nvPr/>
+        </p:nvPicPr>
+        <p:blipFill>
+          <a:blip r:embed="rId3"/>
+          <a:stretch>
+            <a:fillRect/>
+          </a:stretch>
+        </p:blipFill>
+        <p:spPr>
+          <a:xfrm>
+            <a:off x="1143000" y="6847433"/>
+            <a:ext cx="8001000" cy="1422053"/>
+          </a:xfrm>
+          <a:prstGeom prst="rect">
+            <a:avLst/>
+          </a:prstGeom>
+        </p:spPr>
+      </p:pic>
+      <p:sp>
+        <p:nvSpPr>
+          <p:cNvPr id="4" name="B01 프레임"/>
+          <p:cNvSpPr/>
+          <p:nvPr/>
+        </p:nvSpPr>
+        <p:spPr>
+          <a:xfrm>
+            <a:off x="323850" y="323850"/>
+            <a:ext cx="9639300" cy="12211050"/>
+          </a:xfrm>
+          <a:prstGeom prst="roundRect">
+            <a:avLst>
+              <a:gd name="adj" fmla="val 2767"/>
+            </a:avLst>
+          </a:prstGeom>
+          <a:noFill/>
+          <a:ln w="19050">
+            <a:solidFill>
+              <a:srgbClr val="D0DCE5"/>
+            </a:solidFill>
+          </a:ln>
+        </p:spPr>
+        <p:txBody>
+          <a:bodyPr rtlCol="0" anchor="ctr"/>
+          <a:lstStyle/>
+          <a:p>
+            <a:endParaRPr lang="ko-KR"/>
+          </a:p>
+        </p:txBody>
+      </p:sp>
+      <p:sp>
+        <p:nvSpPr>
+          <p:cNvPr id="5" name="텍스트: 그래서 Aspetar는"/>
+          <p:cNvSpPr txBox="1"/>
+          <p:nvPr/>
+        </p:nvSpPr>
+        <p:spPr>
+          <a:xfrm>
+            <a:off x="1609130" y="1029081"/>
+            <a:ext cx="7068741" cy="962025"/>
+          </a:xfrm>
+          <a:prstGeom prst="rect">
+            <a:avLst/>
+          </a:prstGeom>
+          <a:noFill/>
+          <a:ln>
+            <a:noFill/>
+          </a:ln>
+        </p:spPr>
+        <p:txBody>
+          <a:bodyPr vert="horz" wrap="none" lIns="0" tIns="0" rIns="0" bIns="0" rtlCol="0" anchor="ctr" anchorCtr="0">
+            <a:noAutofit/>
+          </a:bodyPr>
+          <a:lstStyle/>
+          <a:p>
+            <a:pPr algn="ctr">
+              <a:lnSpc>
+                <a:spcPct val="100000"/>
+              </a:lnSpc>
+              <a:spcBef>
+                <a:spcPts val="0"/>
+              </a:spcBef>
+              <a:spcAft>
+                <a:spcPts val="0"/>
+              </a:spcAft>
+              <a:buNone/>
+            </a:pPr>
+            <a:r>
+              <a:rPr lang="ko-KR" altLang="en-US" sz="6300" b="0" i="0" spc="-220" kern="0" dirty="0">
+                <a:solidFill>
+                  <a:srgbClr val="121416"/>
+                </a:solidFill>
+                <a:latin typeface="RCardnews W850" pitchFamily="34" charset="-127"/>
+                <a:ea typeface="RCardnews W850" pitchFamily="34" charset="-127"/>
+                <a:cs typeface="RCardnews W850" pitchFamily="34" charset="-127"/>
+              </a:rPr>
+              <a:t xml:space="preserve">그래서 Aspetar는</a:t>
+            </a:r>
+            <a:endParaRPr lang="ko-KR" altLang="en-US" sz="6300" b="0" i="0" spc="-220" kern="0" dirty="0">
+              <a:solidFill>
+                <a:srgbClr val="121416"/>
+              </a:solidFill>
+              <a:latin typeface="RCardnews W850" pitchFamily="34" charset="-127"/>
+              <a:ea typeface="RCardnews W850" pitchFamily="34" charset="-127"/>
+              <a:cs typeface="RCardnews W850" pitchFamily="34" charset="-127"/>
+            </a:endParaRPr>
+          </a:p>
+        </p:txBody>
+      </p:sp>
+      <p:sp>
+        <p:nvSpPr>
+          <p:cNvPr id="6" name="텍스트: 점프의 역학까지"/>
+          <p:cNvSpPr txBox="1"/>
+          <p:nvPr/>
+        </p:nvSpPr>
+        <p:spPr>
+          <a:xfrm>
+            <a:off x="1995636" y="1989171"/>
+            <a:ext cx="6295727" cy="962025"/>
+          </a:xfrm>
+          <a:prstGeom prst="rect">
+            <a:avLst/>
+          </a:prstGeom>
+          <a:noFill/>
+          <a:ln>
+            <a:noFill/>
+          </a:ln>
+        </p:spPr>
+        <p:txBody>
+          <a:bodyPr vert="horz" wrap="none" lIns="0" tIns="0" rIns="0" bIns="0" rtlCol="0" anchor="ctr" anchorCtr="0">
+            <a:noAutofit/>
+          </a:bodyPr>
+          <a:lstStyle/>
+          <a:p>
+            <a:pPr algn="ctr">
+              <a:lnSpc>
+                <a:spcPct val="100000"/>
+              </a:lnSpc>
+              <a:spcBef>
+                <a:spcPts val="0"/>
+              </a:spcBef>
+              <a:spcAft>
+                <a:spcPts val="0"/>
+              </a:spcAft>
+              <a:buNone/>
+            </a:pPr>
+            <a:r>
+              <a:rPr lang="ko-KR" altLang="en-US" sz="6300" b="0" i="0" spc="-220" kern="0" dirty="0">
+                <a:solidFill>
+                  <a:srgbClr val="0879D8"/>
+                </a:solidFill>
+                <a:latin typeface="RCardnews W850" pitchFamily="34" charset="-127"/>
+                <a:ea typeface="RCardnews W850" pitchFamily="34" charset="-127"/>
+                <a:cs typeface="RCardnews W850" pitchFamily="34" charset="-127"/>
+              </a:rPr>
+              <a:t xml:space="preserve">점프의 역학</a:t>
+            </a:r>
+            <a:r>
+              <a:rPr lang="ko-KR" altLang="en-US" sz="6300" b="0" i="0" spc="-220" kern="0" dirty="0">
+                <a:solidFill>
+                  <a:srgbClr val="121416"/>
+                </a:solidFill>
+                <a:latin typeface="RCardnews W850" pitchFamily="34" charset="-127"/>
+                <a:ea typeface="RCardnews W850" pitchFamily="34" charset="-127"/>
+                <a:cs typeface="RCardnews W850" pitchFamily="34" charset="-127"/>
+              </a:rPr>
+              <a:t xml:space="preserve">까지</a:t>
+            </a:r>
+            <a:endParaRPr lang="ko-KR" altLang="en-US" sz="6300" b="0" i="0" spc="-220" kern="0" dirty="0">
+              <a:solidFill>
+                <a:srgbClr val="121416"/>
+              </a:solidFill>
+              <a:latin typeface="RCardnews W850" pitchFamily="34" charset="-127"/>
+              <a:ea typeface="RCardnews W850" pitchFamily="34" charset="-127"/>
+              <a:cs typeface="RCardnews W850" pitchFamily="34" charset="-127"/>
+            </a:endParaRPr>
+          </a:p>
+        </p:txBody>
+      </p:sp>
+      <p:sp>
+        <p:nvSpPr>
+          <p:cNvPr id="7" name="텍스트: 살펴봅니다"/>
+          <p:cNvSpPr txBox="1"/>
+          <p:nvPr/>
+        </p:nvSpPr>
+        <p:spPr>
+          <a:xfrm>
+            <a:off x="2801689" y="2949261"/>
+            <a:ext cx="4683472" cy="962025"/>
+          </a:xfrm>
+          <a:prstGeom prst="rect">
+            <a:avLst/>
+          </a:prstGeom>
+          <a:noFill/>
+          <a:ln>
+            <a:noFill/>
+          </a:ln>
+        </p:spPr>
+        <p:txBody>
+          <a:bodyPr vert="horz" wrap="none" lIns="0" tIns="0" rIns="0" bIns="0" rtlCol="0" anchor="ctr" anchorCtr="0">
+            <a:noAutofit/>
+          </a:bodyPr>
+          <a:lstStyle/>
+          <a:p>
+            <a:pPr algn="ctr">
+              <a:lnSpc>
+                <a:spcPct val="100000"/>
+              </a:lnSpc>
+              <a:spcBef>
+                <a:spcPts val="0"/>
+              </a:spcBef>
+              <a:spcAft>
+                <a:spcPts val="0"/>
+              </a:spcAft>
+              <a:buNone/>
+            </a:pPr>
+            <a:r>
+              <a:rPr lang="ko-KR" altLang="en-US" sz="6300" b="0" i="0" spc="-220" kern="0" dirty="0">
+                <a:solidFill>
+                  <a:srgbClr val="121416"/>
+                </a:solidFill>
+                <a:latin typeface="RCardnews W850" pitchFamily="34" charset="-127"/>
+                <a:ea typeface="RCardnews W850" pitchFamily="34" charset="-127"/>
+                <a:cs typeface="RCardnews W850" pitchFamily="34" charset="-127"/>
+              </a:rPr>
+              <a:t xml:space="preserve">살펴봅니다</a:t>
+            </a:r>
+            <a:endParaRPr lang="ko-KR" altLang="en-US" sz="6300" b="0" i="0" spc="-220" kern="0" dirty="0">
+              <a:solidFill>
+                <a:srgbClr val="121416"/>
+              </a:solidFill>
+              <a:latin typeface="RCardnews W850" pitchFamily="34" charset="-127"/>
+              <a:ea typeface="RCardnews W850" pitchFamily="34" charset="-127"/>
+              <a:cs typeface="RCardnews W850" pitchFamily="34" charset="-127"/>
+            </a:endParaRPr>
+          </a:p>
+        </p:txBody>
+      </p:sp>
+      <p:sp>
+        <p:nvSpPr>
+          <p:cNvPr id="8" name="텍스트: 각도 · 모멘트 · 일"/>
+          <p:cNvSpPr txBox="1"/>
+          <p:nvPr/>
+        </p:nvSpPr>
+        <p:spPr>
+          <a:xfrm>
+            <a:off x="2319486" y="8563237"/>
+            <a:ext cx="5648027" cy="733425"/>
+          </a:xfrm>
+          <a:prstGeom prst="rect">
+            <a:avLst/>
+          </a:prstGeom>
+          <a:noFill/>
+          <a:ln>
+            <a:noFill/>
+          </a:ln>
+        </p:spPr>
+        <p:txBody>
+          <a:bodyPr vert="horz" wrap="none" lIns="0" tIns="0" rIns="0" bIns="0" rtlCol="0" anchor="ctr" anchorCtr="0">
+            <a:noAutofit/>
+          </a:bodyPr>
+          <a:lstStyle/>
+          <a:p>
+            <a:pPr algn="ctr">
+              <a:lnSpc>
+                <a:spcPct val="100000"/>
+              </a:lnSpc>
+              <a:spcBef>
+                <a:spcPts val="0"/>
+              </a:spcBef>
+              <a:spcAft>
+                <a:spcPts val="0"/>
+              </a:spcAft>
+              <a:buNone/>
+            </a:pPr>
+            <a:r>
+              <a:rPr lang="ko-KR" altLang="en-US" sz="4800" b="0" i="0" spc="-144" kern="0" dirty="0">
+                <a:solidFill>
+                  <a:srgbClr val="0879D8"/>
+                </a:solidFill>
+                <a:latin typeface="RCardnews W850" pitchFamily="34" charset="-127"/>
+                <a:ea typeface="RCardnews W850" pitchFamily="34" charset="-127"/>
+                <a:cs typeface="RCardnews W850" pitchFamily="34" charset="-127"/>
+              </a:rPr>
+              <a:t xml:space="preserve">각도 · 모멘트 · 일</a:t>
+            </a:r>
+            <a:endParaRPr lang="ko-KR" altLang="en-US" sz="4800" b="0" i="0" spc="-144" kern="0" dirty="0">
+              <a:solidFill>
+                <a:srgbClr val="0879D8"/>
+              </a:solidFill>
+              <a:latin typeface="RCardnews W850" pitchFamily="34" charset="-127"/>
+              <a:ea typeface="RCardnews W850" pitchFamily="34" charset="-127"/>
+              <a:cs typeface="RCardnews W850" pitchFamily="34" charset="-127"/>
+            </a:endParaRPr>
+          </a:p>
+        </p:txBody>
+      </p:sp>
+      <p:sp>
+        <p:nvSpPr>
+          <p:cNvPr id="9" name="텍스트: 수직·수평 점프에서 고관절·무릎·발목의"/>
+          <p:cNvSpPr txBox="1"/>
+          <p:nvPr/>
+        </p:nvSpPr>
+        <p:spPr>
+          <a:xfrm>
+            <a:off x="1097161" y="9445222"/>
+            <a:ext cx="8092529" cy="504825"/>
+          </a:xfrm>
+          <a:prstGeom prst="rect">
+            <a:avLst/>
+          </a:prstGeom>
+          <a:noFill/>
+          <a:ln>
+            <a:noFill/>
+          </a:ln>
+        </p:spPr>
+        <p:txBody>
+          <a:bodyPr vert="horz" wrap="none" lIns="0" tIns="0" rIns="0" bIns="0" rtlCol="0" anchor="ctr" anchorCtr="0">
+            <a:noAutofit/>
+          </a:bodyPr>
+          <a:lstStyle/>
+          <a:p>
+            <a:pPr algn="ctr">
+              <a:lnSpc>
+                <a:spcPct val="100000"/>
+              </a:lnSpc>
+              <a:spcBef>
+                <a:spcPts val="0"/>
+              </a:spcBef>
+              <a:spcAft>
+                <a:spcPts val="0"/>
+              </a:spcAft>
+              <a:buNone/>
+            </a:pPr>
+            <a:r>
+              <a:rPr lang="ko-KR" altLang="en-US" sz="3300" b="0" i="0" spc="-66" kern="0" dirty="0">
+                <a:solidFill>
+                  <a:srgbClr val="121416"/>
+                </a:solidFill>
+                <a:latin typeface="RCardnews W500" pitchFamily="34" charset="-127"/>
+                <a:ea typeface="RCardnews W500" pitchFamily="34" charset="-127"/>
+                <a:cs typeface="RCardnews W500" pitchFamily="34" charset="-127"/>
+              </a:rPr>
+              <a:t xml:space="preserve">수직·수평 점프에서 고관절·무릎·발목의</a:t>
+            </a:r>
+            <a:endParaRPr lang="ko-KR" altLang="en-US" sz="3300" b="0" i="0" spc="-66" kern="0" dirty="0">
+              <a:solidFill>
+                <a:srgbClr val="121416"/>
+              </a:solidFill>
+              <a:latin typeface="RCardnews W500" pitchFamily="34" charset="-127"/>
+              <a:ea typeface="RCardnews W500" pitchFamily="34" charset="-127"/>
+              <a:cs typeface="RCardnews W500" pitchFamily="34" charset="-127"/>
+            </a:endParaRPr>
+          </a:p>
+        </p:txBody>
+      </p:sp>
+      <p:sp>
+        <p:nvSpPr>
+          <p:cNvPr id="10" name="텍스트: 절대값과 좌우 대칭을 모두 정상 수준으로"/>
+          <p:cNvSpPr txBox="1"/>
+          <p:nvPr/>
+        </p:nvSpPr>
+        <p:spPr>
+          <a:xfrm>
+            <a:off x="1093440" y="10040237"/>
+            <a:ext cx="8100120" cy="504825"/>
+          </a:xfrm>
+          <a:prstGeom prst="rect">
+            <a:avLst/>
+          </a:prstGeom>
+          <a:noFill/>
+          <a:ln>
+            <a:noFill/>
+          </a:ln>
+        </p:spPr>
+        <p:txBody>
+          <a:bodyPr vert="horz" wrap="none" lIns="0" tIns="0" rIns="0" bIns="0" rtlCol="0" anchor="ctr" anchorCtr="0">
+            <a:noAutofit/>
+          </a:bodyPr>
+          <a:lstStyle/>
+          <a:p>
+            <a:pPr algn="ctr">
+              <a:lnSpc>
+                <a:spcPct val="100000"/>
+              </a:lnSpc>
+              <a:spcBef>
+                <a:spcPts val="0"/>
+              </a:spcBef>
+              <a:spcAft>
+                <a:spcPts val="0"/>
+              </a:spcAft>
+              <a:buNone/>
+            </a:pPr>
+            <a:r>
+              <a:rPr lang="ko-KR" altLang="en-US" sz="3300" b="0" i="0" spc="-66" kern="0" dirty="0">
+                <a:solidFill>
+                  <a:srgbClr val="121416"/>
+                </a:solidFill>
+                <a:latin typeface="RCardnews W500" pitchFamily="34" charset="-127"/>
+                <a:ea typeface="RCardnews W500" pitchFamily="34" charset="-127"/>
+                <a:cs typeface="RCardnews W500" pitchFamily="34" charset="-127"/>
+              </a:rPr>
+              <a:t xml:space="preserve">절대값과 좌우 대칭을 모두 정상 수준으로</a:t>
+            </a:r>
+            <a:endParaRPr lang="ko-KR" altLang="en-US" sz="3300" b="0" i="0" spc="-66" kern="0" dirty="0">
+              <a:solidFill>
+                <a:srgbClr val="121416"/>
+              </a:solidFill>
+              <a:latin typeface="RCardnews W500" pitchFamily="34" charset="-127"/>
+              <a:ea typeface="RCardnews W500" pitchFamily="34" charset="-127"/>
+              <a:cs typeface="RCardnews W500" pitchFamily="34" charset="-127"/>
+            </a:endParaRPr>
+          </a:p>
+        </p:txBody>
+      </p:sp>
+      <p:sp>
+        <p:nvSpPr>
+          <p:cNvPr id="11" name="텍스트: 전문 선수의 복귀 평가를 위한 제안이며,"/>
+          <p:cNvSpPr txBox="1"/>
+          <p:nvPr/>
+        </p:nvSpPr>
+        <p:spPr>
+          <a:xfrm>
+            <a:off x="1832372" y="10887855"/>
+            <a:ext cx="6622256" cy="409575"/>
+          </a:xfrm>
+          <a:prstGeom prst="rect">
+            <a:avLst/>
+          </a:prstGeom>
+          <a:noFill/>
+          <a:ln>
+            <a:noFill/>
+          </a:ln>
+        </p:spPr>
+        <p:txBody>
+          <a:bodyPr vert="horz" wrap="none" lIns="0" tIns="0" rIns="0" bIns="0" rtlCol="0" anchor="ctr" anchorCtr="0">
+            <a:noAutofit/>
+          </a:bodyPr>
+          <a:lstStyle/>
+          <a:p>
+            <a:pPr algn="ctr">
+              <a:lnSpc>
+                <a:spcPct val="100000"/>
+              </a:lnSpc>
+              <a:spcBef>
+                <a:spcPts val="0"/>
+              </a:spcBef>
+              <a:spcAft>
+                <a:spcPts val="0"/>
+              </a:spcAft>
+              <a:buNone/>
+            </a:pPr>
+            <a:r>
+              <a:rPr lang="ko-KR" altLang="en-US" sz="2700" b="0" i="0" spc="-54" kern="0" dirty="0">
+                <a:solidFill>
+                  <a:srgbClr val="5E6570"/>
+                </a:solidFill>
+                <a:latin typeface="RCardnews W500" pitchFamily="34" charset="-127"/>
+                <a:ea typeface="RCardnews W500" pitchFamily="34" charset="-127"/>
+                <a:cs typeface="RCardnews W500" pitchFamily="34" charset="-127"/>
+              </a:rPr>
+              <a:t xml:space="preserve">전문 선수의 복귀 평가를 위한 제안이며,</a:t>
+            </a:r>
+            <a:endParaRPr lang="ko-KR" altLang="en-US" sz="2700" b="0" i="0" spc="-54" kern="0" dirty="0">
+              <a:solidFill>
+                <a:srgbClr val="5E6570"/>
+              </a:solidFill>
+              <a:latin typeface="RCardnews W500" pitchFamily="34" charset="-127"/>
+              <a:ea typeface="RCardnews W500" pitchFamily="34" charset="-127"/>
+              <a:cs typeface="RCardnews W500" pitchFamily="34" charset="-127"/>
+            </a:endParaRPr>
+          </a:p>
+        </p:txBody>
+      </p:sp>
+      <p:sp>
+        <p:nvSpPr>
+          <p:cNvPr id="12" name="텍스트: 재부상 예방이 검증된 기준은 아닙니다."/>
+          <p:cNvSpPr txBox="1"/>
+          <p:nvPr/>
+        </p:nvSpPr>
+        <p:spPr>
+          <a:xfrm>
+            <a:off x="1876871" y="11367826"/>
+            <a:ext cx="6533108" cy="409575"/>
+          </a:xfrm>
+          <a:prstGeom prst="rect">
+            <a:avLst/>
+          </a:prstGeom>
+          <a:noFill/>
+          <a:ln>
+            <a:noFill/>
+          </a:ln>
+        </p:spPr>
+        <p:txBody>
+          <a:bodyPr vert="horz" wrap="none" lIns="0" tIns="0" rIns="0" bIns="0" rtlCol="0" anchor="ctr" anchorCtr="0">
+            <a:noAutofit/>
+          </a:bodyPr>
+          <a:lstStyle/>
+          <a:p>
+            <a:pPr algn="ctr">
+              <a:lnSpc>
+                <a:spcPct val="100000"/>
+              </a:lnSpc>
+              <a:spcBef>
+                <a:spcPts val="0"/>
+              </a:spcBef>
+              <a:spcAft>
+                <a:spcPts val="0"/>
+              </a:spcAft>
+              <a:buNone/>
+            </a:pPr>
+            <a:r>
+              <a:rPr lang="ko-KR" altLang="en-US" sz="2700" b="0" i="0" spc="-54" kern="0" dirty="0">
+                <a:solidFill>
+                  <a:srgbClr val="5E6570"/>
+                </a:solidFill>
+                <a:latin typeface="RCardnews W500" pitchFamily="34" charset="-127"/>
+                <a:ea typeface="RCardnews W500" pitchFamily="34" charset="-127"/>
+                <a:cs typeface="RCardnews W500" pitchFamily="34" charset="-127"/>
+              </a:rPr>
+              <a:t xml:space="preserve">재부상 예방이 검증된 기준은 아닙니다.</a:t>
+            </a:r>
+            <a:endParaRPr lang="ko-KR" altLang="en-US" sz="2700" b="0" i="0" spc="-54" kern="0" dirty="0">
+              <a:solidFill>
+                <a:srgbClr val="5E6570"/>
+              </a:solidFill>
+              <a:latin typeface="RCardnews W500" pitchFamily="34" charset="-127"/>
+              <a:ea typeface="RCardnews W500" pitchFamily="34" charset="-127"/>
+              <a:cs typeface="RCardnews W500" pitchFamily="34" charset="-127"/>
+            </a:endParaRPr>
+          </a:p>
+        </p:txBody>
+      </p:sp>
+    </p:spTree>
+  </p:cSld>
+  <p:clrMapOvr>
+    <a:masterClrMapping/>
+  </p:clrMapOvr>
+</p:sld>
+</file>
+
+<file path=ppt/slides/slide7.xml><?xml version="1.0" encoding="utf-8"?>
 <p:sld xmlns:a="http://schemas.openxmlformats.org/drawingml/2006/main" xmlns:r="http://schemas.openxmlformats.org/officeDocument/2006/relationships" xmlns:p="http://schemas.openxmlformats.org/presentationml/2006/main">
   <p:cSld>
     <p:bg>

</xml_diff>